<commit_message>
doing  agent cluster find way to use
</commit_message>
<xml_diff>
--- a/week report/7.28问题.pptx
+++ b/week report/7.28问题.pptx
@@ -204,7 +204,7 @@
           <a:p>
             <a:fld id="{F4BC8E43-2426-4AB4-B1DA-94A32D613D40}" type="datetimeFigureOut">
               <a:rPr lang="zh-CN" altLang="en-US" smtClean="0"/>
-              <a:t>2021/8/4</a:t>
+              <a:t>2021/8/12</a:t>
             </a:fld>
             <a:endParaRPr lang="zh-CN" altLang="en-US"/>
           </a:p>
@@ -975,7 +975,7 @@
           <a:p>
             <a:fld id="{DCC080BC-FD8F-4BC7-912D-250C973482EE}" type="datetimeFigureOut">
               <a:rPr lang="zh-CN" altLang="en-US" smtClean="0"/>
-              <a:t>2021/8/4</a:t>
+              <a:t>2021/8/12</a:t>
             </a:fld>
             <a:endParaRPr lang="zh-CN" altLang="en-US"/>
           </a:p>
@@ -1145,7 +1145,7 @@
           <a:p>
             <a:fld id="{DCC080BC-FD8F-4BC7-912D-250C973482EE}" type="datetimeFigureOut">
               <a:rPr lang="zh-CN" altLang="en-US" smtClean="0"/>
-              <a:t>2021/8/4</a:t>
+              <a:t>2021/8/12</a:t>
             </a:fld>
             <a:endParaRPr lang="zh-CN" altLang="en-US"/>
           </a:p>
@@ -1325,7 +1325,7 @@
           <a:p>
             <a:fld id="{DCC080BC-FD8F-4BC7-912D-250C973482EE}" type="datetimeFigureOut">
               <a:rPr lang="zh-CN" altLang="en-US" smtClean="0"/>
-              <a:t>2021/8/4</a:t>
+              <a:t>2021/8/12</a:t>
             </a:fld>
             <a:endParaRPr lang="zh-CN" altLang="en-US"/>
           </a:p>
@@ -1495,7 +1495,7 @@
           <a:p>
             <a:fld id="{DCC080BC-FD8F-4BC7-912D-250C973482EE}" type="datetimeFigureOut">
               <a:rPr lang="zh-CN" altLang="en-US" smtClean="0"/>
-              <a:t>2021/8/4</a:t>
+              <a:t>2021/8/12</a:t>
             </a:fld>
             <a:endParaRPr lang="zh-CN" altLang="en-US"/>
           </a:p>
@@ -1741,7 +1741,7 @@
           <a:p>
             <a:fld id="{DCC080BC-FD8F-4BC7-912D-250C973482EE}" type="datetimeFigureOut">
               <a:rPr lang="zh-CN" altLang="en-US" smtClean="0"/>
-              <a:t>2021/8/4</a:t>
+              <a:t>2021/8/12</a:t>
             </a:fld>
             <a:endParaRPr lang="zh-CN" altLang="en-US"/>
           </a:p>
@@ -1973,7 +1973,7 @@
           <a:p>
             <a:fld id="{DCC080BC-FD8F-4BC7-912D-250C973482EE}" type="datetimeFigureOut">
               <a:rPr lang="zh-CN" altLang="en-US" smtClean="0"/>
-              <a:t>2021/8/4</a:t>
+              <a:t>2021/8/12</a:t>
             </a:fld>
             <a:endParaRPr lang="zh-CN" altLang="en-US"/>
           </a:p>
@@ -2340,7 +2340,7 @@
           <a:p>
             <a:fld id="{DCC080BC-FD8F-4BC7-912D-250C973482EE}" type="datetimeFigureOut">
               <a:rPr lang="zh-CN" altLang="en-US" smtClean="0"/>
-              <a:t>2021/8/4</a:t>
+              <a:t>2021/8/12</a:t>
             </a:fld>
             <a:endParaRPr lang="zh-CN" altLang="en-US"/>
           </a:p>
@@ -2458,7 +2458,7 @@
           <a:p>
             <a:fld id="{DCC080BC-FD8F-4BC7-912D-250C973482EE}" type="datetimeFigureOut">
               <a:rPr lang="zh-CN" altLang="en-US" smtClean="0"/>
-              <a:t>2021/8/4</a:t>
+              <a:t>2021/8/12</a:t>
             </a:fld>
             <a:endParaRPr lang="zh-CN" altLang="en-US"/>
           </a:p>
@@ -2553,7 +2553,7 @@
           <a:p>
             <a:fld id="{DCC080BC-FD8F-4BC7-912D-250C973482EE}" type="datetimeFigureOut">
               <a:rPr lang="zh-CN" altLang="en-US" smtClean="0"/>
-              <a:t>2021/8/4</a:t>
+              <a:t>2021/8/12</a:t>
             </a:fld>
             <a:endParaRPr lang="zh-CN" altLang="en-US"/>
           </a:p>
@@ -2830,7 +2830,7 @@
           <a:p>
             <a:fld id="{DCC080BC-FD8F-4BC7-912D-250C973482EE}" type="datetimeFigureOut">
               <a:rPr lang="zh-CN" altLang="en-US" smtClean="0"/>
-              <a:t>2021/8/4</a:t>
+              <a:t>2021/8/12</a:t>
             </a:fld>
             <a:endParaRPr lang="zh-CN" altLang="en-US"/>
           </a:p>
@@ -3083,7 +3083,7 @@
           <a:p>
             <a:fld id="{DCC080BC-FD8F-4BC7-912D-250C973482EE}" type="datetimeFigureOut">
               <a:rPr lang="zh-CN" altLang="en-US" smtClean="0"/>
-              <a:t>2021/8/4</a:t>
+              <a:t>2021/8/12</a:t>
             </a:fld>
             <a:endParaRPr lang="zh-CN" altLang="en-US"/>
           </a:p>
@@ -3296,7 +3296,7 @@
           <a:p>
             <a:fld id="{DCC080BC-FD8F-4BC7-912D-250C973482EE}" type="datetimeFigureOut">
               <a:rPr lang="zh-CN" altLang="en-US" smtClean="0"/>
-              <a:t>2021/8/4</a:t>
+              <a:t>2021/8/12</a:t>
             </a:fld>
             <a:endParaRPr lang="zh-CN" altLang="en-US"/>
           </a:p>
@@ -16402,7 +16402,7 @@
           <a:p>
             <a:fld id="{7E66CBCB-337D-49B6-B73D-DC76D0E029C4}" type="datetime1">
               <a:rPr lang="zh-CN" altLang="en-US" smtClean="0"/>
-              <a:t>2021/8/4</a:t>
+              <a:t>2021/8/12</a:t>
             </a:fld>
             <a:endParaRPr lang="zh-CN" altLang="en-US" dirty="0"/>
           </a:p>
@@ -19953,121 +19953,6 @@
           <a:p>
             <a:pPr lvl="0"/>
             <a:endParaRPr lang="zh-CN" altLang="en-US" dirty="0"/>
-          </a:p>
-        </p:txBody>
-      </p:sp>
-      <p:sp>
-        <p:nvSpPr>
-          <p:cNvPr id="4" name="Rectangle 1"/>
-          <p:cNvSpPr>
-            <a:spLocks noChangeArrowheads="1"/>
-          </p:cNvSpPr>
-          <p:nvPr/>
-        </p:nvSpPr>
-        <p:spPr bwMode="auto">
-          <a:xfrm>
-            <a:off x="0" y="0"/>
-            <a:ext cx="12192000" cy="0"/>
-          </a:xfrm>
-          <a:prstGeom prst="rect">
-            <a:avLst/>
-          </a:prstGeom>
-          <a:noFill/>
-          <a:ln>
-            <a:noFill/>
-          </a:ln>
-          <a:effectLst/>
-          <a:extLst>
-            <a:ext uri="{909E8E84-426E-40DD-AFC4-6F175D3DCCD1}">
-              <a14:hiddenFill xmlns:a14="http://schemas.microsoft.com/office/drawing/2010/main">
-                <a:solidFill>
-                  <a:schemeClr val="accent1"/>
-                </a:solidFill>
-              </a14:hiddenFill>
-            </a:ext>
-            <a:ext uri="{91240B29-F687-4F45-9708-019B960494DF}">
-              <a14:hiddenLine xmlns:a14="http://schemas.microsoft.com/office/drawing/2010/main" w="9525">
-                <a:solidFill>
-                  <a:schemeClr val="tx1"/>
-                </a:solidFill>
-                <a:miter lim="800000"/>
-                <a:headEnd/>
-                <a:tailEnd/>
-              </a14:hiddenLine>
-            </a:ext>
-            <a:ext uri="{AF507438-7753-43E0-B8FC-AC1667EBCBE1}">
-              <a14:hiddenEffects xmlns:a14="http://schemas.microsoft.com/office/drawing/2010/main">
-                <a:effectLst>
-                  <a:outerShdw dist="35921" dir="2700000" algn="ctr" rotWithShape="0">
-                    <a:schemeClr val="bg2"/>
-                  </a:outerShdw>
-                </a:effectLst>
-              </a14:hiddenEffects>
-            </a:ext>
-          </a:extLst>
-        </p:spPr>
-        <p:txBody>
-          <a:bodyPr vert="horz" wrap="none" lIns="91440" tIns="45720" rIns="91440" bIns="45720" numCol="1" anchor="ctr" anchorCtr="0" compatLnSpc="1">
-            <a:prstTxWarp prst="textNoShape">
-              <a:avLst/>
-            </a:prstTxWarp>
-            <a:spAutoFit/>
-          </a:bodyPr>
-          <a:lstStyle/>
-          <a:p>
-            <a:pPr marL="0" marR="0" lvl="0" indent="0" algn="l" defTabSz="914400" rtl="0" eaLnBrk="0" fontAlgn="base" latinLnBrk="0" hangingPunct="0">
-              <a:lnSpc>
-                <a:spcPct val="100000"/>
-              </a:lnSpc>
-              <a:spcBef>
-                <a:spcPct val="0"/>
-              </a:spcBef>
-              <a:spcAft>
-                <a:spcPct val="0"/>
-              </a:spcAft>
-              <a:buClrTx/>
-              <a:buSzTx/>
-              <a:buFontTx/>
-              <a:buNone/>
-              <a:tabLst/>
-            </a:pPr>
-            <a:r>
-              <a:rPr kumimoji="0" lang="zh-CN" altLang="zh-CN" sz="1200" b="0" i="0" u="none" strike="noStrike" cap="none" normalizeH="0" baseline="0" smtClean="0">
-                <a:ln>
-                  <a:noFill/>
-                </a:ln>
-                <a:solidFill>
-                  <a:srgbClr val="B8BFC6"/>
-                </a:solidFill>
-                <a:effectLst/>
-                <a:latin typeface="Arial" panose="020B0604020202020204" pitchFamily="34" charset="0"/>
-                <a:ea typeface="Helvetica Neue"/>
-              </a:rPr>
-              <a:t>For r and w(p), I tried several combinations and chose the one with the best performance.</a:t>
-            </a:r>
-            <a:r>
-              <a:rPr kumimoji="0" lang="zh-CN" altLang="zh-CN" sz="800" b="0" i="0" u="none" strike="noStrike" cap="none" normalizeH="0" baseline="0" smtClean="0">
-                <a:ln>
-                  <a:noFill/>
-                </a:ln>
-                <a:solidFill>
-                  <a:schemeClr val="tx1"/>
-                </a:solidFill>
-                <a:effectLst/>
-                <a:latin typeface="Arial" panose="020B0604020202020204" pitchFamily="34" charset="0"/>
-              </a:rPr>
-              <a:t> </a:t>
-            </a:r>
-            <a:endParaRPr kumimoji="0" lang="zh-CN" altLang="zh-CN" sz="1800" b="0" i="0" u="none" strike="noStrike" cap="none" normalizeH="0" baseline="0" smtClean="0">
-              <a:ln>
-                <a:noFill/>
-              </a:ln>
-              <a:solidFill>
-                <a:schemeClr val="tx1"/>
-              </a:solidFill>
-              <a:effectLst/>
-              <a:latin typeface="Arial" panose="020B0604020202020204" pitchFamily="34" charset="0"/>
-            </a:endParaRPr>
           </a:p>
         </p:txBody>
       </p:sp>

</xml_diff>

<commit_message>
finisshed ppt , need add result
</commit_message>
<xml_diff>
--- a/week report/7.28问题.pptx
+++ b/week report/7.28问题.pptx
@@ -204,7 +204,7 @@
           <a:p>
             <a:fld id="{F4BC8E43-2426-4AB4-B1DA-94A32D613D40}" type="datetimeFigureOut">
               <a:rPr lang="zh-CN" altLang="en-US" smtClean="0"/>
-              <a:t>2021/8/12</a:t>
+              <a:t>2021/8/22</a:t>
             </a:fld>
             <a:endParaRPr lang="zh-CN" altLang="en-US"/>
           </a:p>
@@ -975,7 +975,7 @@
           <a:p>
             <a:fld id="{DCC080BC-FD8F-4BC7-912D-250C973482EE}" type="datetimeFigureOut">
               <a:rPr lang="zh-CN" altLang="en-US" smtClean="0"/>
-              <a:t>2021/8/12</a:t>
+              <a:t>2021/8/22</a:t>
             </a:fld>
             <a:endParaRPr lang="zh-CN" altLang="en-US"/>
           </a:p>
@@ -1145,7 +1145,7 @@
           <a:p>
             <a:fld id="{DCC080BC-FD8F-4BC7-912D-250C973482EE}" type="datetimeFigureOut">
               <a:rPr lang="zh-CN" altLang="en-US" smtClean="0"/>
-              <a:t>2021/8/12</a:t>
+              <a:t>2021/8/22</a:t>
             </a:fld>
             <a:endParaRPr lang="zh-CN" altLang="en-US"/>
           </a:p>
@@ -1325,7 +1325,7 @@
           <a:p>
             <a:fld id="{DCC080BC-FD8F-4BC7-912D-250C973482EE}" type="datetimeFigureOut">
               <a:rPr lang="zh-CN" altLang="en-US" smtClean="0"/>
-              <a:t>2021/8/12</a:t>
+              <a:t>2021/8/22</a:t>
             </a:fld>
             <a:endParaRPr lang="zh-CN" altLang="en-US"/>
           </a:p>
@@ -1495,7 +1495,7 @@
           <a:p>
             <a:fld id="{DCC080BC-FD8F-4BC7-912D-250C973482EE}" type="datetimeFigureOut">
               <a:rPr lang="zh-CN" altLang="en-US" smtClean="0"/>
-              <a:t>2021/8/12</a:t>
+              <a:t>2021/8/22</a:t>
             </a:fld>
             <a:endParaRPr lang="zh-CN" altLang="en-US"/>
           </a:p>
@@ -1741,7 +1741,7 @@
           <a:p>
             <a:fld id="{DCC080BC-FD8F-4BC7-912D-250C973482EE}" type="datetimeFigureOut">
               <a:rPr lang="zh-CN" altLang="en-US" smtClean="0"/>
-              <a:t>2021/8/12</a:t>
+              <a:t>2021/8/22</a:t>
             </a:fld>
             <a:endParaRPr lang="zh-CN" altLang="en-US"/>
           </a:p>
@@ -1973,7 +1973,7 @@
           <a:p>
             <a:fld id="{DCC080BC-FD8F-4BC7-912D-250C973482EE}" type="datetimeFigureOut">
               <a:rPr lang="zh-CN" altLang="en-US" smtClean="0"/>
-              <a:t>2021/8/12</a:t>
+              <a:t>2021/8/22</a:t>
             </a:fld>
             <a:endParaRPr lang="zh-CN" altLang="en-US"/>
           </a:p>
@@ -2340,7 +2340,7 @@
           <a:p>
             <a:fld id="{DCC080BC-FD8F-4BC7-912D-250C973482EE}" type="datetimeFigureOut">
               <a:rPr lang="zh-CN" altLang="en-US" smtClean="0"/>
-              <a:t>2021/8/12</a:t>
+              <a:t>2021/8/22</a:t>
             </a:fld>
             <a:endParaRPr lang="zh-CN" altLang="en-US"/>
           </a:p>
@@ -2458,7 +2458,7 @@
           <a:p>
             <a:fld id="{DCC080BC-FD8F-4BC7-912D-250C973482EE}" type="datetimeFigureOut">
               <a:rPr lang="zh-CN" altLang="en-US" smtClean="0"/>
-              <a:t>2021/8/12</a:t>
+              <a:t>2021/8/22</a:t>
             </a:fld>
             <a:endParaRPr lang="zh-CN" altLang="en-US"/>
           </a:p>
@@ -2553,7 +2553,7 @@
           <a:p>
             <a:fld id="{DCC080BC-FD8F-4BC7-912D-250C973482EE}" type="datetimeFigureOut">
               <a:rPr lang="zh-CN" altLang="en-US" smtClean="0"/>
-              <a:t>2021/8/12</a:t>
+              <a:t>2021/8/22</a:t>
             </a:fld>
             <a:endParaRPr lang="zh-CN" altLang="en-US"/>
           </a:p>
@@ -2830,7 +2830,7 @@
           <a:p>
             <a:fld id="{DCC080BC-FD8F-4BC7-912D-250C973482EE}" type="datetimeFigureOut">
               <a:rPr lang="zh-CN" altLang="en-US" smtClean="0"/>
-              <a:t>2021/8/12</a:t>
+              <a:t>2021/8/22</a:t>
             </a:fld>
             <a:endParaRPr lang="zh-CN" altLang="en-US"/>
           </a:p>
@@ -3083,7 +3083,7 @@
           <a:p>
             <a:fld id="{DCC080BC-FD8F-4BC7-912D-250C973482EE}" type="datetimeFigureOut">
               <a:rPr lang="zh-CN" altLang="en-US" smtClean="0"/>
-              <a:t>2021/8/12</a:t>
+              <a:t>2021/8/22</a:t>
             </a:fld>
             <a:endParaRPr lang="zh-CN" altLang="en-US"/>
           </a:p>
@@ -3296,7 +3296,7 @@
           <a:p>
             <a:fld id="{DCC080BC-FD8F-4BC7-912D-250C973482EE}" type="datetimeFigureOut">
               <a:rPr lang="zh-CN" altLang="en-US" smtClean="0"/>
-              <a:t>2021/8/12</a:t>
+              <a:t>2021/8/22</a:t>
             </a:fld>
             <a:endParaRPr lang="zh-CN" altLang="en-US"/>
           </a:p>
@@ -16402,7 +16402,7 @@
           <a:p>
             <a:fld id="{7E66CBCB-337D-49B6-B73D-DC76D0E029C4}" type="datetime1">
               <a:rPr lang="zh-CN" altLang="en-US" smtClean="0"/>
-              <a:t>2021/8/12</a:t>
+              <a:t>2021/8/22</a:t>
             </a:fld>
             <a:endParaRPr lang="zh-CN" altLang="en-US" dirty="0"/>
           </a:p>
@@ -16988,12 +16988,10 @@
               <a:t>有助于收敛</a:t>
             </a:r>
             <a:r>
-              <a:rPr lang="en-US" altLang="zh-CN" dirty="0"/>
+              <a:rPr lang="en-US" altLang="zh-CN" dirty="0" smtClean="0"/>
               <a:t>.</a:t>
             </a:r>
-          </a:p>
-          <a:p>
-            <a:endParaRPr lang="en-US" altLang="zh-CN" dirty="0" smtClean="0"/>
+            <a:endParaRPr lang="en-US" altLang="zh-CN" dirty="0"/>
           </a:p>
         </p:txBody>
       </p:sp>

</xml_diff>